<commit_message>
Presentacion proyecto fase 2
</commit_message>
<xml_diff>
--- a/AV_AM_800D_EquipoTechnicalBridge/Fase 2/Evidencias Proyecto/Presentación Proyecto.pptx
+++ b/AV_AM_800D_EquipoTechnicalBridge/Fase 2/Evidencias Proyecto/Presentación Proyecto.pptx
@@ -8416,7 +8416,7 @@
         </p:nvSpPr>
         <p:spPr>
           <a:xfrm>
-            <a:off x="12241977" y="2635257"/>
+            <a:off x="12871182" y="2230427"/>
             <a:ext cx="4406941" cy="5754286"/>
           </a:xfrm>
           <a:custGeom>
@@ -8470,7 +8470,7 @@
         <p:spPr>
           <a:xfrm>
             <a:off x="1028700" y="3545010"/>
-            <a:ext cx="7983713" cy="3749120"/>
+            <a:ext cx="7983713" cy="4330481"/>
           </a:xfrm>
           <a:prstGeom prst="rect">
             <a:avLst/>
@@ -8488,7 +8488,7 @@
               </a:lnSpc>
             </a:pPr>
             <a:r>
-              <a:rPr lang="en-US" sz="2396" b="1">
+              <a:rPr lang="en-US" sz="2396" b="1" dirty="0">
                 <a:solidFill>
                   <a:srgbClr val="05061C"/>
                 </a:solidFill>
@@ -8497,7 +8497,535 @@
                 <a:cs typeface="Canva Sans Bold"/>
                 <a:sym typeface="Canva Sans Bold"/>
               </a:rPr>
-              <a:t>El proyecto se sitúa en la gestión de cobranza de empresas que necesitan organizar sus carteras y dar seguimiento a obligaciones pendientes. Para representar este escenario, se utilizan empresas ficticias, como APOFYX, que permiten demostrar la carga de carteras y su administración mediante campañas. DataBridge es el producto central y no depende exclusivamente de estos clientes de prueba.</a:t>
+              <a:t>El proyecto se </a:t>
+            </a:r>
+            <a:r>
+              <a:rPr lang="en-US" sz="2396" b="1" dirty="0" err="1">
+                <a:solidFill>
+                  <a:srgbClr val="05061C"/>
+                </a:solidFill>
+                <a:latin typeface="Canva Sans Bold"/>
+                <a:ea typeface="Canva Sans Bold"/>
+                <a:cs typeface="Canva Sans Bold"/>
+                <a:sym typeface="Canva Sans Bold"/>
+              </a:rPr>
+              <a:t>sitúa</a:t>
+            </a:r>
+            <a:r>
+              <a:rPr lang="en-US" sz="2396" b="1" dirty="0">
+                <a:solidFill>
+                  <a:srgbClr val="05061C"/>
+                </a:solidFill>
+                <a:latin typeface="Canva Sans Bold"/>
+                <a:ea typeface="Canva Sans Bold"/>
+                <a:cs typeface="Canva Sans Bold"/>
+                <a:sym typeface="Canva Sans Bold"/>
+              </a:rPr>
+              <a:t> </a:t>
+            </a:r>
+            <a:r>
+              <a:rPr lang="en-US" sz="2396" b="1" dirty="0" err="1">
+                <a:solidFill>
+                  <a:srgbClr val="05061C"/>
+                </a:solidFill>
+                <a:latin typeface="Canva Sans Bold"/>
+                <a:ea typeface="Canva Sans Bold"/>
+                <a:cs typeface="Canva Sans Bold"/>
+                <a:sym typeface="Canva Sans Bold"/>
+              </a:rPr>
+              <a:t>en</a:t>
+            </a:r>
+            <a:r>
+              <a:rPr lang="en-US" sz="2396" b="1" dirty="0">
+                <a:solidFill>
+                  <a:srgbClr val="05061C"/>
+                </a:solidFill>
+                <a:latin typeface="Canva Sans Bold"/>
+                <a:ea typeface="Canva Sans Bold"/>
+                <a:cs typeface="Canva Sans Bold"/>
+                <a:sym typeface="Canva Sans Bold"/>
+              </a:rPr>
+              <a:t> la </a:t>
+            </a:r>
+            <a:r>
+              <a:rPr lang="en-US" sz="2396" b="1" dirty="0" err="1">
+                <a:solidFill>
+                  <a:srgbClr val="05061C"/>
+                </a:solidFill>
+                <a:latin typeface="Canva Sans Bold"/>
+                <a:ea typeface="Canva Sans Bold"/>
+                <a:cs typeface="Canva Sans Bold"/>
+                <a:sym typeface="Canva Sans Bold"/>
+              </a:rPr>
+              <a:t>gestión</a:t>
+            </a:r>
+            <a:r>
+              <a:rPr lang="en-US" sz="2396" b="1" dirty="0">
+                <a:solidFill>
+                  <a:srgbClr val="05061C"/>
+                </a:solidFill>
+                <a:latin typeface="Canva Sans Bold"/>
+                <a:ea typeface="Canva Sans Bold"/>
+                <a:cs typeface="Canva Sans Bold"/>
+                <a:sym typeface="Canva Sans Bold"/>
+              </a:rPr>
+              <a:t> de </a:t>
+            </a:r>
+            <a:r>
+              <a:rPr lang="en-US" sz="2396" b="1" dirty="0" err="1">
+                <a:solidFill>
+                  <a:srgbClr val="05061C"/>
+                </a:solidFill>
+                <a:latin typeface="Canva Sans Bold"/>
+                <a:ea typeface="Canva Sans Bold"/>
+                <a:cs typeface="Canva Sans Bold"/>
+                <a:sym typeface="Canva Sans Bold"/>
+              </a:rPr>
+              <a:t>cobranza</a:t>
+            </a:r>
+            <a:r>
+              <a:rPr lang="en-US" sz="2396" b="1" dirty="0">
+                <a:solidFill>
+                  <a:srgbClr val="05061C"/>
+                </a:solidFill>
+                <a:latin typeface="Canva Sans Bold"/>
+                <a:ea typeface="Canva Sans Bold"/>
+                <a:cs typeface="Canva Sans Bold"/>
+                <a:sym typeface="Canva Sans Bold"/>
+              </a:rPr>
+              <a:t> de </a:t>
+            </a:r>
+            <a:r>
+              <a:rPr lang="en-US" sz="2396" b="1" dirty="0" err="1">
+                <a:solidFill>
+                  <a:srgbClr val="05061C"/>
+                </a:solidFill>
+                <a:latin typeface="Canva Sans Bold"/>
+                <a:ea typeface="Canva Sans Bold"/>
+                <a:cs typeface="Canva Sans Bold"/>
+                <a:sym typeface="Canva Sans Bold"/>
+              </a:rPr>
+              <a:t>empresas</a:t>
+            </a:r>
+            <a:r>
+              <a:rPr lang="en-US" sz="2396" b="1" dirty="0">
+                <a:solidFill>
+                  <a:srgbClr val="05061C"/>
+                </a:solidFill>
+                <a:latin typeface="Canva Sans Bold"/>
+                <a:ea typeface="Canva Sans Bold"/>
+                <a:cs typeface="Canva Sans Bold"/>
+                <a:sym typeface="Canva Sans Bold"/>
+              </a:rPr>
+              <a:t> </a:t>
+            </a:r>
+            <a:r>
+              <a:rPr lang="en-US" sz="2396" b="1" dirty="0" err="1">
+                <a:solidFill>
+                  <a:srgbClr val="05061C"/>
+                </a:solidFill>
+                <a:latin typeface="Canva Sans Bold"/>
+                <a:ea typeface="Canva Sans Bold"/>
+                <a:cs typeface="Canva Sans Bold"/>
+                <a:sym typeface="Canva Sans Bold"/>
+              </a:rPr>
+              <a:t>que</a:t>
+            </a:r>
+            <a:r>
+              <a:rPr lang="en-US" sz="2396" b="1" dirty="0">
+                <a:solidFill>
+                  <a:srgbClr val="05061C"/>
+                </a:solidFill>
+                <a:latin typeface="Canva Sans Bold"/>
+                <a:ea typeface="Canva Sans Bold"/>
+                <a:cs typeface="Canva Sans Bold"/>
+                <a:sym typeface="Canva Sans Bold"/>
+              </a:rPr>
+              <a:t> </a:t>
+            </a:r>
+            <a:r>
+              <a:rPr lang="en-US" sz="2396" b="1" dirty="0" err="1">
+                <a:solidFill>
+                  <a:srgbClr val="05061C"/>
+                </a:solidFill>
+                <a:latin typeface="Canva Sans Bold"/>
+                <a:ea typeface="Canva Sans Bold"/>
+                <a:cs typeface="Canva Sans Bold"/>
+                <a:sym typeface="Canva Sans Bold"/>
+              </a:rPr>
+              <a:t>necesitan</a:t>
+            </a:r>
+            <a:r>
+              <a:rPr lang="en-US" sz="2396" b="1" dirty="0">
+                <a:solidFill>
+                  <a:srgbClr val="05061C"/>
+                </a:solidFill>
+                <a:latin typeface="Canva Sans Bold"/>
+                <a:ea typeface="Canva Sans Bold"/>
+                <a:cs typeface="Canva Sans Bold"/>
+                <a:sym typeface="Canva Sans Bold"/>
+              </a:rPr>
+              <a:t> </a:t>
+            </a:r>
+            <a:r>
+              <a:rPr lang="en-US" sz="2396" b="1" dirty="0" err="1">
+                <a:solidFill>
+                  <a:srgbClr val="05061C"/>
+                </a:solidFill>
+                <a:latin typeface="Canva Sans Bold"/>
+                <a:ea typeface="Canva Sans Bold"/>
+                <a:cs typeface="Canva Sans Bold"/>
+                <a:sym typeface="Canva Sans Bold"/>
+              </a:rPr>
+              <a:t>organizar</a:t>
+            </a:r>
+            <a:r>
+              <a:rPr lang="en-US" sz="2396" b="1" dirty="0">
+                <a:solidFill>
+                  <a:srgbClr val="05061C"/>
+                </a:solidFill>
+                <a:latin typeface="Canva Sans Bold"/>
+                <a:ea typeface="Canva Sans Bold"/>
+                <a:cs typeface="Canva Sans Bold"/>
+                <a:sym typeface="Canva Sans Bold"/>
+              </a:rPr>
+              <a:t> sus </a:t>
+            </a:r>
+            <a:r>
+              <a:rPr lang="en-US" sz="2396" b="1" dirty="0" err="1">
+                <a:solidFill>
+                  <a:srgbClr val="05061C"/>
+                </a:solidFill>
+                <a:latin typeface="Canva Sans Bold"/>
+                <a:ea typeface="Canva Sans Bold"/>
+                <a:cs typeface="Canva Sans Bold"/>
+                <a:sym typeface="Canva Sans Bold"/>
+              </a:rPr>
+              <a:t>carteras</a:t>
+            </a:r>
+            <a:r>
+              <a:rPr lang="en-US" sz="2396" b="1" dirty="0">
+                <a:solidFill>
+                  <a:srgbClr val="05061C"/>
+                </a:solidFill>
+                <a:latin typeface="Canva Sans Bold"/>
+                <a:ea typeface="Canva Sans Bold"/>
+                <a:cs typeface="Canva Sans Bold"/>
+                <a:sym typeface="Canva Sans Bold"/>
+              </a:rPr>
+              <a:t> y </a:t>
+            </a:r>
+            <a:r>
+              <a:rPr lang="en-US" sz="2396" b="1" dirty="0" err="1">
+                <a:solidFill>
+                  <a:srgbClr val="05061C"/>
+                </a:solidFill>
+                <a:latin typeface="Canva Sans Bold"/>
+                <a:ea typeface="Canva Sans Bold"/>
+                <a:cs typeface="Canva Sans Bold"/>
+                <a:sym typeface="Canva Sans Bold"/>
+              </a:rPr>
+              <a:t>dar</a:t>
+            </a:r>
+            <a:r>
+              <a:rPr lang="en-US" sz="2396" b="1" dirty="0">
+                <a:solidFill>
+                  <a:srgbClr val="05061C"/>
+                </a:solidFill>
+                <a:latin typeface="Canva Sans Bold"/>
+                <a:ea typeface="Canva Sans Bold"/>
+                <a:cs typeface="Canva Sans Bold"/>
+                <a:sym typeface="Canva Sans Bold"/>
+              </a:rPr>
+              <a:t> </a:t>
+            </a:r>
+            <a:r>
+              <a:rPr lang="en-US" sz="2396" b="1" dirty="0" err="1">
+                <a:solidFill>
+                  <a:srgbClr val="05061C"/>
+                </a:solidFill>
+                <a:latin typeface="Canva Sans Bold"/>
+                <a:ea typeface="Canva Sans Bold"/>
+                <a:cs typeface="Canva Sans Bold"/>
+                <a:sym typeface="Canva Sans Bold"/>
+              </a:rPr>
+              <a:t>seguimiento</a:t>
+            </a:r>
+            <a:r>
+              <a:rPr lang="en-US" sz="2396" b="1" dirty="0">
+                <a:solidFill>
+                  <a:srgbClr val="05061C"/>
+                </a:solidFill>
+                <a:latin typeface="Canva Sans Bold"/>
+                <a:ea typeface="Canva Sans Bold"/>
+                <a:cs typeface="Canva Sans Bold"/>
+                <a:sym typeface="Canva Sans Bold"/>
+              </a:rPr>
+              <a:t> a </a:t>
+            </a:r>
+            <a:r>
+              <a:rPr lang="en-US" sz="2396" b="1" dirty="0" err="1">
+                <a:solidFill>
+                  <a:srgbClr val="05061C"/>
+                </a:solidFill>
+                <a:latin typeface="Canva Sans Bold"/>
+                <a:ea typeface="Canva Sans Bold"/>
+                <a:cs typeface="Canva Sans Bold"/>
+                <a:sym typeface="Canva Sans Bold"/>
+              </a:rPr>
+              <a:t>obligaciones</a:t>
+            </a:r>
+            <a:r>
+              <a:rPr lang="en-US" sz="2396" b="1" dirty="0">
+                <a:solidFill>
+                  <a:srgbClr val="05061C"/>
+                </a:solidFill>
+                <a:latin typeface="Canva Sans Bold"/>
+                <a:ea typeface="Canva Sans Bold"/>
+                <a:cs typeface="Canva Sans Bold"/>
+                <a:sym typeface="Canva Sans Bold"/>
+              </a:rPr>
+              <a:t> </a:t>
+            </a:r>
+            <a:r>
+              <a:rPr lang="en-US" sz="2396" b="1" dirty="0" err="1">
+                <a:solidFill>
+                  <a:srgbClr val="05061C"/>
+                </a:solidFill>
+                <a:latin typeface="Canva Sans Bold"/>
+                <a:ea typeface="Canva Sans Bold"/>
+                <a:cs typeface="Canva Sans Bold"/>
+                <a:sym typeface="Canva Sans Bold"/>
+              </a:rPr>
+              <a:t>pendientes</a:t>
+            </a:r>
+            <a:r>
+              <a:rPr lang="en-US" sz="2396" b="1" dirty="0">
+                <a:solidFill>
+                  <a:srgbClr val="05061C"/>
+                </a:solidFill>
+                <a:latin typeface="Canva Sans Bold"/>
+                <a:ea typeface="Canva Sans Bold"/>
+                <a:cs typeface="Canva Sans Bold"/>
+                <a:sym typeface="Canva Sans Bold"/>
+              </a:rPr>
+              <a:t>, para </a:t>
+            </a:r>
+            <a:r>
+              <a:rPr lang="en-US" sz="2396" b="1" dirty="0" err="1">
+                <a:solidFill>
+                  <a:srgbClr val="05061C"/>
+                </a:solidFill>
+                <a:latin typeface="Canva Sans Bold"/>
+                <a:ea typeface="Canva Sans Bold"/>
+                <a:cs typeface="Canva Sans Bold"/>
+                <a:sym typeface="Canva Sans Bold"/>
+              </a:rPr>
+              <a:t>una</a:t>
+            </a:r>
+            <a:r>
+              <a:rPr lang="en-US" sz="2396" b="1" dirty="0">
+                <a:solidFill>
+                  <a:srgbClr val="05061C"/>
+                </a:solidFill>
+                <a:latin typeface="Canva Sans Bold"/>
+                <a:ea typeface="Canva Sans Bold"/>
+                <a:cs typeface="Canva Sans Bold"/>
+                <a:sym typeface="Canva Sans Bold"/>
+              </a:rPr>
+              <a:t> </a:t>
+            </a:r>
+            <a:r>
+              <a:rPr lang="en-US" sz="2396" b="1" dirty="0" err="1">
+                <a:solidFill>
+                  <a:srgbClr val="05061C"/>
+                </a:solidFill>
+                <a:latin typeface="Canva Sans Bold"/>
+                <a:ea typeface="Canva Sans Bold"/>
+                <a:cs typeface="Canva Sans Bold"/>
+                <a:sym typeface="Canva Sans Bold"/>
+              </a:rPr>
+              <a:t>migracion</a:t>
+            </a:r>
+            <a:r>
+              <a:rPr lang="en-US" sz="2396" b="1" dirty="0">
+                <a:solidFill>
+                  <a:srgbClr val="05061C"/>
+                </a:solidFill>
+                <a:latin typeface="Canva Sans Bold"/>
+                <a:ea typeface="Canva Sans Bold"/>
+                <a:cs typeface="Canva Sans Bold"/>
+                <a:sym typeface="Canva Sans Bold"/>
+              </a:rPr>
+              <a:t> APOFYX </a:t>
+            </a:r>
+            <a:r>
+              <a:rPr lang="en-US" sz="2396" b="1" dirty="0" err="1">
+                <a:solidFill>
+                  <a:srgbClr val="05061C"/>
+                </a:solidFill>
+                <a:latin typeface="Canva Sans Bold"/>
+                <a:ea typeface="Canva Sans Bold"/>
+                <a:cs typeface="Canva Sans Bold"/>
+                <a:sym typeface="Canva Sans Bold"/>
+              </a:rPr>
+              <a:t>DataBridge</a:t>
+            </a:r>
+            <a:r>
+              <a:rPr lang="en-US" sz="2396" b="1" dirty="0">
+                <a:solidFill>
+                  <a:srgbClr val="05061C"/>
+                </a:solidFill>
+                <a:latin typeface="Canva Sans Bold"/>
+                <a:ea typeface="Canva Sans Bold"/>
+                <a:cs typeface="Canva Sans Bold"/>
+                <a:sym typeface="Canva Sans Bold"/>
+              </a:rPr>
+              <a:t> es el </a:t>
+            </a:r>
+            <a:r>
+              <a:rPr lang="en-US" sz="2396" b="1" dirty="0" err="1">
+                <a:solidFill>
+                  <a:srgbClr val="05061C"/>
+                </a:solidFill>
+                <a:latin typeface="Canva Sans Bold"/>
+                <a:ea typeface="Canva Sans Bold"/>
+                <a:cs typeface="Canva Sans Bold"/>
+                <a:sym typeface="Canva Sans Bold"/>
+              </a:rPr>
+              <a:t>producto</a:t>
+            </a:r>
+            <a:r>
+              <a:rPr lang="en-US" sz="2396" b="1" dirty="0">
+                <a:solidFill>
+                  <a:srgbClr val="05061C"/>
+                </a:solidFill>
+                <a:latin typeface="Canva Sans Bold"/>
+                <a:ea typeface="Canva Sans Bold"/>
+                <a:cs typeface="Canva Sans Bold"/>
+                <a:sym typeface="Canva Sans Bold"/>
+              </a:rPr>
+              <a:t> central y no </a:t>
+            </a:r>
+            <a:r>
+              <a:rPr lang="en-US" sz="2396" b="1" dirty="0" err="1">
+                <a:solidFill>
+                  <a:srgbClr val="05061C"/>
+                </a:solidFill>
+                <a:latin typeface="Canva Sans Bold"/>
+                <a:ea typeface="Canva Sans Bold"/>
+                <a:cs typeface="Canva Sans Bold"/>
+                <a:sym typeface="Canva Sans Bold"/>
+              </a:rPr>
+              <a:t>depende</a:t>
+            </a:r>
+            <a:r>
+              <a:rPr lang="en-US" sz="2396" b="1" dirty="0">
+                <a:solidFill>
+                  <a:srgbClr val="05061C"/>
+                </a:solidFill>
+                <a:latin typeface="Canva Sans Bold"/>
+                <a:ea typeface="Canva Sans Bold"/>
+                <a:cs typeface="Canva Sans Bold"/>
+                <a:sym typeface="Canva Sans Bold"/>
+              </a:rPr>
+              <a:t> </a:t>
+            </a:r>
+            <a:r>
+              <a:rPr lang="en-US" sz="2396" b="1" dirty="0" err="1">
+                <a:solidFill>
+                  <a:srgbClr val="05061C"/>
+                </a:solidFill>
+                <a:latin typeface="Canva Sans Bold"/>
+                <a:ea typeface="Canva Sans Bold"/>
+                <a:cs typeface="Canva Sans Bold"/>
+                <a:sym typeface="Canva Sans Bold"/>
+              </a:rPr>
+              <a:t>exclusivamente</a:t>
+            </a:r>
+            <a:r>
+              <a:rPr lang="en-US" sz="2396" b="1" dirty="0">
+                <a:solidFill>
+                  <a:srgbClr val="05061C"/>
+                </a:solidFill>
+                <a:latin typeface="Canva Sans Bold"/>
+                <a:ea typeface="Canva Sans Bold"/>
+                <a:cs typeface="Canva Sans Bold"/>
+                <a:sym typeface="Canva Sans Bold"/>
+              </a:rPr>
+              <a:t> de </a:t>
+            </a:r>
+            <a:r>
+              <a:rPr lang="en-US" sz="2396" b="1" dirty="0" err="1">
+                <a:solidFill>
+                  <a:srgbClr val="05061C"/>
+                </a:solidFill>
+                <a:latin typeface="Canva Sans Bold"/>
+                <a:ea typeface="Canva Sans Bold"/>
+                <a:cs typeface="Canva Sans Bold"/>
+                <a:sym typeface="Canva Sans Bold"/>
+              </a:rPr>
+              <a:t>estos</a:t>
+            </a:r>
+            <a:r>
+              <a:rPr lang="en-US" sz="2396" b="1" dirty="0">
+                <a:solidFill>
+                  <a:srgbClr val="05061C"/>
+                </a:solidFill>
+                <a:latin typeface="Canva Sans Bold"/>
+                <a:ea typeface="Canva Sans Bold"/>
+                <a:cs typeface="Canva Sans Bold"/>
+                <a:sym typeface="Canva Sans Bold"/>
+              </a:rPr>
+              <a:t> </a:t>
+            </a:r>
+            <a:r>
+              <a:rPr lang="en-US" sz="2396" b="1" dirty="0" err="1">
+                <a:solidFill>
+                  <a:srgbClr val="05061C"/>
+                </a:solidFill>
+                <a:latin typeface="Canva Sans Bold"/>
+                <a:ea typeface="Canva Sans Bold"/>
+                <a:cs typeface="Canva Sans Bold"/>
+                <a:sym typeface="Canva Sans Bold"/>
+              </a:rPr>
+              <a:t>clientes</a:t>
+            </a:r>
+            <a:r>
+              <a:rPr lang="en-US" sz="2396" b="1" dirty="0">
+                <a:solidFill>
+                  <a:srgbClr val="05061C"/>
+                </a:solidFill>
+                <a:latin typeface="Canva Sans Bold"/>
+                <a:ea typeface="Canva Sans Bold"/>
+                <a:cs typeface="Canva Sans Bold"/>
+                <a:sym typeface="Canva Sans Bold"/>
+              </a:rPr>
+              <a:t> de </a:t>
+            </a:r>
+            <a:r>
+              <a:rPr lang="en-US" sz="2396" b="1" dirty="0" err="1">
+                <a:solidFill>
+                  <a:srgbClr val="05061C"/>
+                </a:solidFill>
+                <a:latin typeface="Canva Sans Bold"/>
+                <a:ea typeface="Canva Sans Bold"/>
+                <a:cs typeface="Canva Sans Bold"/>
+                <a:sym typeface="Canva Sans Bold"/>
+              </a:rPr>
+              <a:t>prueba</a:t>
+            </a:r>
+            <a:r>
+              <a:rPr lang="en-US" sz="2396" b="1" dirty="0">
+                <a:solidFill>
+                  <a:srgbClr val="05061C"/>
+                </a:solidFill>
+                <a:latin typeface="Canva Sans Bold"/>
+                <a:ea typeface="Canva Sans Bold"/>
+                <a:cs typeface="Canva Sans Bold"/>
+                <a:sym typeface="Canva Sans Bold"/>
+              </a:rPr>
+              <a:t>.</a:t>
             </a:r>
           </a:p>
           <a:p>
@@ -8506,7 +9034,242 @@
                 <a:spcPts val="3355"/>
               </a:lnSpc>
             </a:pPr>
-            <a:endParaRPr lang="en-US" sz="2396" b="1">
+            <a:r>
+              <a:rPr lang="en-US" sz="2396" b="1" dirty="0">
+                <a:solidFill>
+                  <a:srgbClr val="05061C"/>
+                </a:solidFill>
+                <a:latin typeface="Canva Sans Bold"/>
+                <a:ea typeface="Canva Sans Bold"/>
+                <a:cs typeface="Canva Sans Bold"/>
+                <a:sym typeface="Canva Sans Bold"/>
+              </a:rPr>
+              <a:t>Se </a:t>
+            </a:r>
+            <a:r>
+              <a:rPr lang="en-US" sz="2396" b="1" dirty="0" err="1">
+                <a:solidFill>
+                  <a:srgbClr val="05061C"/>
+                </a:solidFill>
+                <a:latin typeface="Canva Sans Bold"/>
+                <a:ea typeface="Canva Sans Bold"/>
+                <a:cs typeface="Canva Sans Bold"/>
+                <a:sym typeface="Canva Sans Bold"/>
+              </a:rPr>
+              <a:t>decidió</a:t>
+            </a:r>
+            <a:r>
+              <a:rPr lang="en-US" sz="2396" b="1" dirty="0">
+                <a:solidFill>
+                  <a:srgbClr val="05061C"/>
+                </a:solidFill>
+                <a:latin typeface="Canva Sans Bold"/>
+                <a:ea typeface="Canva Sans Bold"/>
+                <a:cs typeface="Canva Sans Bold"/>
+                <a:sym typeface="Canva Sans Bold"/>
+              </a:rPr>
+              <a:t> </a:t>
+            </a:r>
+            <a:r>
+              <a:rPr lang="en-US" sz="2396" b="1" dirty="0" err="1">
+                <a:solidFill>
+                  <a:srgbClr val="05061C"/>
+                </a:solidFill>
+                <a:latin typeface="Canva Sans Bold"/>
+                <a:ea typeface="Canva Sans Bold"/>
+                <a:cs typeface="Canva Sans Bold"/>
+                <a:sym typeface="Canva Sans Bold"/>
+              </a:rPr>
+              <a:t>continuar</a:t>
+            </a:r>
+            <a:r>
+              <a:rPr lang="en-US" sz="2396" b="1" dirty="0">
+                <a:solidFill>
+                  <a:srgbClr val="05061C"/>
+                </a:solidFill>
+                <a:latin typeface="Canva Sans Bold"/>
+                <a:ea typeface="Canva Sans Bold"/>
+                <a:cs typeface="Canva Sans Bold"/>
+                <a:sym typeface="Canva Sans Bold"/>
+              </a:rPr>
+              <a:t> </a:t>
+            </a:r>
+            <a:r>
+              <a:rPr lang="en-US" sz="2396" b="1" dirty="0" err="1">
+                <a:solidFill>
+                  <a:srgbClr val="05061C"/>
+                </a:solidFill>
+                <a:latin typeface="Canva Sans Bold"/>
+                <a:ea typeface="Canva Sans Bold"/>
+                <a:cs typeface="Canva Sans Bold"/>
+                <a:sym typeface="Canva Sans Bold"/>
+              </a:rPr>
+              <a:t>en</a:t>
+            </a:r>
+            <a:r>
+              <a:rPr lang="en-US" sz="2396" b="1" dirty="0">
+                <a:solidFill>
+                  <a:srgbClr val="05061C"/>
+                </a:solidFill>
+                <a:latin typeface="Canva Sans Bold"/>
+                <a:ea typeface="Canva Sans Bold"/>
+                <a:cs typeface="Canva Sans Bold"/>
+                <a:sym typeface="Canva Sans Bold"/>
+              </a:rPr>
+              <a:t> la gestion de </a:t>
+            </a:r>
+            <a:r>
+              <a:rPr lang="en-US" sz="2396" b="1" dirty="0" err="1">
+                <a:solidFill>
+                  <a:srgbClr val="05061C"/>
+                </a:solidFill>
+                <a:latin typeface="Canva Sans Bold"/>
+                <a:ea typeface="Canva Sans Bold"/>
+                <a:cs typeface="Canva Sans Bold"/>
+                <a:sym typeface="Canva Sans Bold"/>
+              </a:rPr>
+              <a:t>cobranza</a:t>
+            </a:r>
+            <a:r>
+              <a:rPr lang="en-US" sz="2396" b="1" dirty="0">
+                <a:solidFill>
+                  <a:srgbClr val="05061C"/>
+                </a:solidFill>
+                <a:latin typeface="Canva Sans Bold"/>
+                <a:ea typeface="Canva Sans Bold"/>
+                <a:cs typeface="Canva Sans Bold"/>
+                <a:sym typeface="Canva Sans Bold"/>
+              </a:rPr>
+              <a:t> para </a:t>
+            </a:r>
+            <a:r>
+              <a:rPr lang="en-US" sz="2396" b="1" dirty="0" err="1">
+                <a:solidFill>
+                  <a:srgbClr val="05061C"/>
+                </a:solidFill>
+                <a:latin typeface="Canva Sans Bold"/>
+                <a:ea typeface="Canva Sans Bold"/>
+                <a:cs typeface="Canva Sans Bold"/>
+                <a:sym typeface="Canva Sans Bold"/>
+              </a:rPr>
+              <a:t>una</a:t>
+            </a:r>
+            <a:r>
+              <a:rPr lang="en-US" sz="2396" b="1" dirty="0">
+                <a:solidFill>
+                  <a:srgbClr val="05061C"/>
+                </a:solidFill>
+                <a:latin typeface="Canva Sans Bold"/>
+                <a:ea typeface="Canva Sans Bold"/>
+                <a:cs typeface="Canva Sans Bold"/>
+                <a:sym typeface="Canva Sans Bold"/>
+              </a:rPr>
+              <a:t> </a:t>
+            </a:r>
+            <a:r>
+              <a:rPr lang="en-US" sz="2396" b="1" dirty="0" err="1">
+                <a:solidFill>
+                  <a:srgbClr val="05061C"/>
+                </a:solidFill>
+                <a:latin typeface="Canva Sans Bold"/>
+                <a:ea typeface="Canva Sans Bold"/>
+                <a:cs typeface="Canva Sans Bold"/>
+                <a:sym typeface="Canva Sans Bold"/>
+              </a:rPr>
+              <a:t>migración</a:t>
+            </a:r>
+            <a:r>
+              <a:rPr lang="en-US" sz="2396" b="1" dirty="0">
+                <a:solidFill>
+                  <a:srgbClr val="05061C"/>
+                </a:solidFill>
+                <a:latin typeface="Canva Sans Bold"/>
+                <a:ea typeface="Canva Sans Bold"/>
+                <a:cs typeface="Canva Sans Bold"/>
+                <a:sym typeface="Canva Sans Bold"/>
+              </a:rPr>
+              <a:t> mas viable del </a:t>
+            </a:r>
+            <a:r>
+              <a:rPr lang="en-US" sz="2396" b="1" dirty="0" err="1">
+                <a:solidFill>
+                  <a:srgbClr val="05061C"/>
+                </a:solidFill>
+                <a:latin typeface="Canva Sans Bold"/>
+                <a:ea typeface="Canva Sans Bold"/>
+                <a:cs typeface="Canva Sans Bold"/>
+                <a:sym typeface="Canva Sans Bold"/>
+              </a:rPr>
+              <a:t>cliente</a:t>
+            </a:r>
+            <a:r>
+              <a:rPr lang="en-US" sz="2396" b="1" dirty="0">
+                <a:solidFill>
+                  <a:srgbClr val="05061C"/>
+                </a:solidFill>
+                <a:latin typeface="Canva Sans Bold"/>
+                <a:ea typeface="Canva Sans Bold"/>
+                <a:cs typeface="Canva Sans Bold"/>
+                <a:sym typeface="Canva Sans Bold"/>
+              </a:rPr>
+              <a:t>, luego de la </a:t>
+            </a:r>
+            <a:r>
+              <a:rPr lang="en-US" sz="2396" b="1" dirty="0" err="1">
+                <a:solidFill>
+                  <a:srgbClr val="05061C"/>
+                </a:solidFill>
+                <a:latin typeface="Canva Sans Bold"/>
+                <a:ea typeface="Canva Sans Bold"/>
+                <a:cs typeface="Canva Sans Bold"/>
+                <a:sym typeface="Canva Sans Bold"/>
+              </a:rPr>
+              <a:t>desvinculación</a:t>
+            </a:r>
+            <a:r>
+              <a:rPr lang="en-US" sz="2396" b="1" dirty="0">
+                <a:solidFill>
+                  <a:srgbClr val="05061C"/>
+                </a:solidFill>
+                <a:latin typeface="Canva Sans Bold"/>
+                <a:ea typeface="Canva Sans Bold"/>
+                <a:cs typeface="Canva Sans Bold"/>
+                <a:sym typeface="Canva Sans Bold"/>
+              </a:rPr>
+              <a:t> del </a:t>
+            </a:r>
+            <a:r>
+              <a:rPr lang="en-US" sz="2396" b="1" dirty="0" err="1">
+                <a:solidFill>
+                  <a:srgbClr val="05061C"/>
+                </a:solidFill>
+                <a:latin typeface="Canva Sans Bold"/>
+                <a:ea typeface="Canva Sans Bold"/>
+                <a:cs typeface="Canva Sans Bold"/>
+                <a:sym typeface="Canva Sans Bold"/>
+              </a:rPr>
+              <a:t>cliente</a:t>
+            </a:r>
+            <a:r>
+              <a:rPr lang="en-US" sz="2396" b="1" dirty="0">
+                <a:solidFill>
+                  <a:srgbClr val="05061C"/>
+                </a:solidFill>
+                <a:latin typeface="Canva Sans Bold"/>
+                <a:ea typeface="Canva Sans Bold"/>
+                <a:cs typeface="Canva Sans Bold"/>
+                <a:sym typeface="Canva Sans Bold"/>
+              </a:rPr>
+              <a:t> de la Fase 1.</a:t>
+            </a:r>
+          </a:p>
+          <a:p>
+            <a:pPr algn="l">
+              <a:lnSpc>
+                <a:spcPts val="3355"/>
+              </a:lnSpc>
+            </a:pPr>
+            <a:endParaRPr lang="en-US" sz="2396" b="1" dirty="0">
               <a:solidFill>
                 <a:srgbClr val="05061C"/>
               </a:solidFill>
@@ -8526,7 +9289,7 @@
         </p:nvSpPr>
         <p:spPr>
           <a:xfrm>
-            <a:off x="1028700" y="2075857"/>
+            <a:off x="457200" y="1638300"/>
             <a:ext cx="9498942" cy="1614825"/>
           </a:xfrm>
           <a:prstGeom prst="rect">
@@ -8545,7 +9308,7 @@
               </a:lnSpc>
             </a:pPr>
             <a:r>
-              <a:rPr lang="en-US" sz="9400">
+              <a:rPr lang="en-US" sz="9400" dirty="0" err="1">
                 <a:solidFill>
                   <a:srgbClr val="05061C"/>
                 </a:solidFill>
@@ -8556,6 +9319,15 @@
               </a:rPr>
               <a:t>contexto</a:t>
             </a:r>
+            <a:endParaRPr lang="en-US" sz="9400" dirty="0">
+              <a:solidFill>
+                <a:srgbClr val="05061C"/>
+              </a:solidFill>
+              <a:latin typeface="Mokoto"/>
+              <a:ea typeface="Mokoto"/>
+              <a:cs typeface="Mokoto"/>
+              <a:sym typeface="Mokoto"/>
+            </a:endParaRPr>
           </a:p>
         </p:txBody>
       </p:sp>

</xml_diff>